<commit_message>
M03: natural-complexity restructure (HTML + PPTX)
- Cara Kerja: dropped forced 5th step, now 4 real steps, title de-numbered
- Kesalahan Umum: red warning panel instead of purple pill grid (matches HTML's own tip-box.warn styling, which the deck had been ignoring)
- Yang Kamu Butuhkan relocated to Contoh Prompt slide footer, same pattern as M02
- Cover: dropped '-- 12 menit' duration text
</commit_message>
<xml_diff>
--- a/Content-Marketing/M03-Konten-Instagram/K3-M03-Sistem-Konten-Instagram.pptx
+++ b/Content-Marketing/M03-Konten-Instagram/K3-M03-Sistem-Konten-Instagram.pptx
@@ -1657,7 +1657,7 @@
                 <a:ea typeface="Helvetica" pitchFamily="34" charset="-122"/>
                 <a:cs typeface="Helvetica" pitchFamily="34" charset="-120"/>
               </a:rPr>
-              <a:t>Kalender 30 hari selesai dalam 1 sesi — 12 menit</a:t>
+              <a:t>Kalender 30 hari selesai dalam 1 sesi</a:t>
             </a:r>
             <a:endParaRPr lang="en-US" sz="1550" dirty="0"/>
           </a:p>
@@ -3139,65 +3139,26 @@
       </p:sp>
       <p:sp>
         <p:nvSpPr>
-          <p:cNvPr id="18" name="Text 16"/>
-          <p:cNvSpPr/>
-          <p:nvPr/>
-        </p:nvSpPr>
-        <p:spPr>
-          <a:xfrm>
-            <a:off x="502920" y="3749040"/>
-            <a:ext cx="11064240" cy="274320"/>
-          </a:xfrm>
-          <a:prstGeom prst="rect">
-            <a:avLst/>
-          </a:prstGeom>
-          <a:noFill/>
-          <a:ln/>
-        </p:spPr>
-        <p:txBody>
-          <a:bodyPr wrap="square" lIns="0" tIns="0" rIns="0" bIns="0" rtlCol="0" anchor="ctr"/>
-          <a:lstStyle/>
-          <a:p>
-            <a:pPr indent="0" marL="0">
-              <a:buNone/>
-            </a:pPr>
-            <a:r>
-              <a:rPr lang="en-US" sz="1250" b="1" spc="40" kern="0" dirty="0">
-                <a:solidFill>
-                  <a:srgbClr val="4B36C7"/>
-                </a:solidFill>
-                <a:latin typeface="Helvetica" pitchFamily="34" charset="0"/>
-                <a:ea typeface="Helvetica" pitchFamily="34" charset="-122"/>
-                <a:cs typeface="Helvetica" pitchFamily="34" charset="-120"/>
-              </a:rPr>
-              <a:t>KESALAHAN UMUM</a:t>
-            </a:r>
-            <a:endParaRPr lang="en-US" sz="1250" dirty="0"/>
-          </a:p>
-        </p:txBody>
-      </p:sp>
-      <p:sp>
-        <p:nvSpPr>
-          <p:cNvPr id="19" name="Shape 17"/>
-          <p:cNvSpPr/>
-          <p:nvPr/>
-        </p:nvSpPr>
-        <p:spPr>
-          <a:xfrm>
-            <a:off x="502920" y="4078224"/>
-            <a:ext cx="2487168" cy="566928"/>
+          <p:cNvPr id="18" name="Shape 16"/>
+          <p:cNvSpPr/>
+          <p:nvPr/>
+        </p:nvSpPr>
+        <p:spPr>
+          <a:xfrm>
+            <a:off x="502920" y="3767328"/>
+            <a:ext cx="11064240" cy="1691640"/>
           </a:xfrm>
           <a:prstGeom prst="roundRect">
             <a:avLst>
-              <a:gd name="adj" fmla="val 16129"/>
+              <a:gd name="adj" fmla="val 5405"/>
             </a:avLst>
           </a:prstGeom>
           <a:solidFill>
-            <a:srgbClr val="F3F0FF"/>
+            <a:srgbClr val="FFF6F6"/>
           </a:solidFill>
           <a:ln w="12700">
             <a:solidFill>
-              <a:srgbClr val="DCD3FB"/>
+              <a:srgbClr val="F3C6C6"/>
             </a:solidFill>
             <a:prstDash val="solid"/>
           </a:ln>
@@ -3205,14 +3166,92 @@
       </p:sp>
       <p:sp>
         <p:nvSpPr>
+          <p:cNvPr id="19" name="Text 17"/>
+          <p:cNvSpPr/>
+          <p:nvPr/>
+        </p:nvSpPr>
+        <p:spPr>
+          <a:xfrm>
+            <a:off x="713232" y="3913632"/>
+            <a:ext cx="10607040" cy="274320"/>
+          </a:xfrm>
+          <a:prstGeom prst="rect">
+            <a:avLst/>
+          </a:prstGeom>
+          <a:noFill/>
+          <a:ln/>
+        </p:spPr>
+        <p:txBody>
+          <a:bodyPr wrap="square" lIns="0" tIns="0" rIns="0" bIns="0" rtlCol="0" anchor="ctr"/>
+          <a:lstStyle/>
+          <a:p>
+            <a:pPr indent="0" marL="0">
+              <a:buNone/>
+            </a:pPr>
+            <a:r>
+              <a:rPr lang="en-US" sz="1250" b="1" spc="40" kern="0" dirty="0">
+                <a:solidFill>
+                  <a:srgbClr val="DC2626"/>
+                </a:solidFill>
+                <a:latin typeface="Helvetica" pitchFamily="34" charset="0"/>
+                <a:ea typeface="Helvetica" pitchFamily="34" charset="-122"/>
+                <a:cs typeface="Helvetica" pitchFamily="34" charset="-120"/>
+              </a:rPr>
+              <a:t>KESALAHAN UMUM</a:t>
+            </a:r>
+            <a:endParaRPr lang="en-US" sz="1250" dirty="0"/>
+          </a:p>
+        </p:txBody>
+      </p:sp>
+      <p:sp>
+        <p:nvSpPr>
           <p:cNvPr id="20" name="Text 18"/>
           <p:cNvSpPr/>
           <p:nvPr/>
         </p:nvSpPr>
         <p:spPr>
           <a:xfrm>
-            <a:off x="640080" y="4078224"/>
-            <a:ext cx="2212848" cy="566928"/>
+            <a:off x="713232" y="4215384"/>
+            <a:ext cx="219456" cy="274320"/>
+          </a:xfrm>
+          <a:prstGeom prst="rect">
+            <a:avLst/>
+          </a:prstGeom>
+          <a:noFill/>
+          <a:ln/>
+        </p:spPr>
+        <p:txBody>
+          <a:bodyPr wrap="square" lIns="0" tIns="0" rIns="0" bIns="0" rtlCol="0" anchor="ctr"/>
+          <a:lstStyle/>
+          <a:p>
+            <a:pPr indent="0" marL="0">
+              <a:buNone/>
+            </a:pPr>
+            <a:r>
+              <a:rPr lang="en-US" sz="1300" b="1" dirty="0">
+                <a:solidFill>
+                  <a:srgbClr val="DC2626"/>
+                </a:solidFill>
+                <a:latin typeface="Helvetica" pitchFamily="34" charset="0"/>
+                <a:ea typeface="Helvetica" pitchFamily="34" charset="-122"/>
+                <a:cs typeface="Helvetica" pitchFamily="34" charset="-120"/>
+              </a:rPr>
+              <a:t>×</a:t>
+            </a:r>
+            <a:endParaRPr lang="en-US" sz="1300" dirty="0"/>
+          </a:p>
+        </p:txBody>
+      </p:sp>
+      <p:sp>
+        <p:nvSpPr>
+          <p:cNvPr id="21" name="Text 19"/>
+          <p:cNvSpPr/>
+          <p:nvPr/>
+        </p:nvSpPr>
+        <p:spPr>
+          <a:xfrm>
+            <a:off x="950976" y="4187952"/>
+            <a:ext cx="10378440" cy="329184"/>
           </a:xfrm>
           <a:prstGeom prst="rect">
             <a:avLst/>
@@ -3226,82 +3265,155 @@
           <a:p>
             <a:pPr indent="0" marL="0">
               <a:lnSpc>
-                <a:spcPct val="110000"/>
+                <a:spcPct val="115000"/>
               </a:lnSpc>
               <a:buNone/>
             </a:pPr>
             <a:r>
-              <a:rPr lang="en-US" sz="1050" b="1" dirty="0">
-                <a:solidFill>
-                  <a:srgbClr val="4B36C7"/>
-                </a:solidFill>
-                <a:latin typeface="Helvetica" pitchFamily="34" charset="0"/>
-                <a:ea typeface="Helvetica" pitchFamily="34" charset="-122"/>
-                <a:cs typeface="Helvetica" pitchFamily="34" charset="-120"/>
-              </a:rPr>
-              <a:t>Posting tanpa</a:t>
-            </a:r>
-            <a:endParaRPr lang="en-US" sz="1050" dirty="0"/>
-          </a:p>
+              <a:rPr lang="en-US" sz="1100" dirty="0">
+                <a:solidFill>
+                  <a:srgbClr val="7A3B3B"/>
+                </a:solidFill>
+                <a:latin typeface="Helvetica" pitchFamily="34" charset="0"/>
+                <a:ea typeface="Helvetica" pitchFamily="34" charset="-122"/>
+                <a:cs typeface="Helvetica" pitchFamily="34" charset="-120"/>
+              </a:rPr>
+              <a:t>Posting tanpa tema — audiens tidak dapat kesan brand konsisten, growth stagnan</a:t>
+            </a:r>
+            <a:endParaRPr lang="en-US" sz="1100" dirty="0"/>
+          </a:p>
+        </p:txBody>
+      </p:sp>
+      <p:sp>
+        <p:nvSpPr>
+          <p:cNvPr id="22" name="Text 20"/>
+          <p:cNvSpPr/>
+          <p:nvPr/>
+        </p:nvSpPr>
+        <p:spPr>
+          <a:xfrm>
+            <a:off x="713232" y="4512564"/>
+            <a:ext cx="219456" cy="274320"/>
+          </a:xfrm>
+          <a:prstGeom prst="rect">
+            <a:avLst/>
+          </a:prstGeom>
+          <a:noFill/>
+          <a:ln/>
+        </p:spPr>
+        <p:txBody>
+          <a:bodyPr wrap="square" lIns="0" tIns="0" rIns="0" bIns="0" rtlCol="0" anchor="ctr"/>
+          <a:lstStyle/>
+          <a:p>
+            <a:pPr indent="0" marL="0">
+              <a:buNone/>
+            </a:pPr>
+            <a:r>
+              <a:rPr lang="en-US" sz="1300" b="1" dirty="0">
+                <a:solidFill>
+                  <a:srgbClr val="DC2626"/>
+                </a:solidFill>
+                <a:latin typeface="Helvetica" pitchFamily="34" charset="0"/>
+                <a:ea typeface="Helvetica" pitchFamily="34" charset="-122"/>
+                <a:cs typeface="Helvetica" pitchFamily="34" charset="-120"/>
+              </a:rPr>
+              <a:t>×</a:t>
+            </a:r>
+            <a:endParaRPr lang="en-US" sz="1300" dirty="0"/>
+          </a:p>
+        </p:txBody>
+      </p:sp>
+      <p:sp>
+        <p:nvSpPr>
+          <p:cNvPr id="23" name="Text 21"/>
+          <p:cNvSpPr/>
+          <p:nvPr/>
+        </p:nvSpPr>
+        <p:spPr>
+          <a:xfrm>
+            <a:off x="950976" y="4485132"/>
+            <a:ext cx="10378440" cy="329184"/>
+          </a:xfrm>
+          <a:prstGeom prst="rect">
+            <a:avLst/>
+          </a:prstGeom>
+          <a:noFill/>
+          <a:ln/>
+        </p:spPr>
+        <p:txBody>
+          <a:bodyPr wrap="square" lIns="0" tIns="0" rIns="0" bIns="0" rtlCol="0" anchor="ctr"/>
+          <a:lstStyle/>
           <a:p>
             <a:pPr indent="0" marL="0">
               <a:lnSpc>
-                <a:spcPct val="110000"/>
+                <a:spcPct val="115000"/>
               </a:lnSpc>
               <a:buNone/>
             </a:pPr>
             <a:r>
-              <a:rPr lang="en-US" sz="1050" b="1" dirty="0">
-                <a:solidFill>
-                  <a:srgbClr val="4B36C7"/>
-                </a:solidFill>
-                <a:latin typeface="Helvetica" pitchFamily="34" charset="0"/>
-                <a:ea typeface="Helvetica" pitchFamily="34" charset="-122"/>
-                <a:cs typeface="Helvetica" pitchFamily="34" charset="-120"/>
-              </a:rPr>
-              <a:t>tema</a:t>
-            </a:r>
-            <a:endParaRPr lang="en-US" sz="1050" dirty="0"/>
-          </a:p>
-        </p:txBody>
-      </p:sp>
-      <p:sp>
-        <p:nvSpPr>
-          <p:cNvPr id="21" name="Shape 19"/>
-          <p:cNvSpPr/>
-          <p:nvPr/>
-        </p:nvSpPr>
-        <p:spPr>
-          <a:xfrm>
-            <a:off x="3108960" y="4078224"/>
-            <a:ext cx="2487168" cy="566928"/>
-          </a:xfrm>
-          <a:prstGeom prst="roundRect">
-            <a:avLst>
-              <a:gd name="adj" fmla="val 16129"/>
-            </a:avLst>
-          </a:prstGeom>
-          <a:solidFill>
-            <a:srgbClr val="F3F0FF"/>
-          </a:solidFill>
-          <a:ln w="12700">
-            <a:solidFill>
-              <a:srgbClr val="DCD3FB"/>
-            </a:solidFill>
-            <a:prstDash val="solid"/>
-          </a:ln>
-        </p:spPr>
-      </p:sp>
-      <p:sp>
-        <p:nvSpPr>
-          <p:cNvPr id="22" name="Text 20"/>
-          <p:cNvSpPr/>
-          <p:nvPr/>
-        </p:nvSpPr>
-        <p:spPr>
-          <a:xfrm>
-            <a:off x="3246120" y="4078224"/>
-            <a:ext cx="2212848" cy="566928"/>
+              <a:rPr lang="en-US" sz="1100" dirty="0">
+                <a:solidFill>
+                  <a:srgbClr val="7A3B3B"/>
+                </a:solidFill>
+                <a:latin typeface="Helvetica" pitchFamily="34" charset="0"/>
+                <a:ea typeface="Helvetica" pitchFamily="34" charset="-122"/>
+                <a:cs typeface="Helvetica" pitchFamily="34" charset="-120"/>
+              </a:rPr>
+              <a:t>Caption terlalu panjang — 80% audiens tidak baca lebih dari 2 baris pertama</a:t>
+            </a:r>
+            <a:endParaRPr lang="en-US" sz="1100" dirty="0"/>
+          </a:p>
+        </p:txBody>
+      </p:sp>
+      <p:sp>
+        <p:nvSpPr>
+          <p:cNvPr id="24" name="Text 22"/>
+          <p:cNvSpPr/>
+          <p:nvPr/>
+        </p:nvSpPr>
+        <p:spPr>
+          <a:xfrm>
+            <a:off x="713232" y="4809744"/>
+            <a:ext cx="219456" cy="274320"/>
+          </a:xfrm>
+          <a:prstGeom prst="rect">
+            <a:avLst/>
+          </a:prstGeom>
+          <a:noFill/>
+          <a:ln/>
+        </p:spPr>
+        <p:txBody>
+          <a:bodyPr wrap="square" lIns="0" tIns="0" rIns="0" bIns="0" rtlCol="0" anchor="ctr"/>
+          <a:lstStyle/>
+          <a:p>
+            <a:pPr indent="0" marL="0">
+              <a:buNone/>
+            </a:pPr>
+            <a:r>
+              <a:rPr lang="en-US" sz="1300" b="1" dirty="0">
+                <a:solidFill>
+                  <a:srgbClr val="DC2626"/>
+                </a:solidFill>
+                <a:latin typeface="Helvetica" pitchFamily="34" charset="0"/>
+                <a:ea typeface="Helvetica" pitchFamily="34" charset="-122"/>
+                <a:cs typeface="Helvetica" pitchFamily="34" charset="-120"/>
+              </a:rPr>
+              <a:t>×</a:t>
+            </a:r>
+            <a:endParaRPr lang="en-US" sz="1300" dirty="0"/>
+          </a:p>
+        </p:txBody>
+      </p:sp>
+      <p:sp>
+        <p:nvSpPr>
+          <p:cNvPr id="25" name="Text 23"/>
+          <p:cNvSpPr/>
+          <p:nvPr/>
+        </p:nvSpPr>
+        <p:spPr>
+          <a:xfrm>
+            <a:off x="950976" y="4782312"/>
+            <a:ext cx="10378440" cy="329184"/>
           </a:xfrm>
           <a:prstGeom prst="rect">
             <a:avLst/>
@@ -3315,306 +3427,103 @@
           <a:p>
             <a:pPr indent="0" marL="0">
               <a:lnSpc>
-                <a:spcPct val="110000"/>
+                <a:spcPct val="115000"/>
               </a:lnSpc>
               <a:buNone/>
             </a:pPr>
             <a:r>
-              <a:rPr lang="en-US" sz="1050" b="1" dirty="0">
-                <a:solidFill>
-                  <a:srgbClr val="4B36C7"/>
-                </a:solidFill>
-                <a:latin typeface="Helvetica" pitchFamily="34" charset="0"/>
-                <a:ea typeface="Helvetica" pitchFamily="34" charset="-122"/>
-                <a:cs typeface="Helvetica" pitchFamily="34" charset="-120"/>
-              </a:rPr>
-              <a:t>Caption terlalu</a:t>
-            </a:r>
-            <a:endParaRPr lang="en-US" sz="1050" dirty="0"/>
-          </a:p>
+              <a:rPr lang="en-US" sz="1100" dirty="0">
+                <a:solidFill>
+                  <a:srgbClr val="7A3B3B"/>
+                </a:solidFill>
+                <a:latin typeface="Helvetica" pitchFamily="34" charset="0"/>
+                <a:ea typeface="Helvetica" pitchFamily="34" charset="-122"/>
+                <a:cs typeface="Helvetica" pitchFamily="34" charset="-120"/>
+              </a:rPr>
+              <a:t>Hashtag asal tempel — campurkan hashtag besar (1M+) dan niche (10K-100K)</a:t>
+            </a:r>
+            <a:endParaRPr lang="en-US" sz="1100" dirty="0"/>
+          </a:p>
+        </p:txBody>
+      </p:sp>
+      <p:sp>
+        <p:nvSpPr>
+          <p:cNvPr id="26" name="Text 24"/>
+          <p:cNvSpPr/>
+          <p:nvPr/>
+        </p:nvSpPr>
+        <p:spPr>
+          <a:xfrm>
+            <a:off x="713232" y="5106924"/>
+            <a:ext cx="219456" cy="274320"/>
+          </a:xfrm>
+          <a:prstGeom prst="rect">
+            <a:avLst/>
+          </a:prstGeom>
+          <a:noFill/>
+          <a:ln/>
+        </p:spPr>
+        <p:txBody>
+          <a:bodyPr wrap="square" lIns="0" tIns="0" rIns="0" bIns="0" rtlCol="0" anchor="ctr"/>
+          <a:lstStyle/>
+          <a:p>
+            <a:pPr indent="0" marL="0">
+              <a:buNone/>
+            </a:pPr>
+            <a:r>
+              <a:rPr lang="en-US" sz="1300" b="1" dirty="0">
+                <a:solidFill>
+                  <a:srgbClr val="DC2626"/>
+                </a:solidFill>
+                <a:latin typeface="Helvetica" pitchFamily="34" charset="0"/>
+                <a:ea typeface="Helvetica" pitchFamily="34" charset="-122"/>
+                <a:cs typeface="Helvetica" pitchFamily="34" charset="-120"/>
+              </a:rPr>
+              <a:t>×</a:t>
+            </a:r>
+            <a:endParaRPr lang="en-US" sz="1300" dirty="0"/>
+          </a:p>
+        </p:txBody>
+      </p:sp>
+      <p:sp>
+        <p:nvSpPr>
+          <p:cNvPr id="27" name="Text 25"/>
+          <p:cNvSpPr/>
+          <p:nvPr/>
+        </p:nvSpPr>
+        <p:spPr>
+          <a:xfrm>
+            <a:off x="950976" y="5079492"/>
+            <a:ext cx="10378440" cy="329184"/>
+          </a:xfrm>
+          <a:prstGeom prst="rect">
+            <a:avLst/>
+          </a:prstGeom>
+          <a:noFill/>
+          <a:ln/>
+        </p:spPr>
+        <p:txBody>
+          <a:bodyPr wrap="square" lIns="0" tIns="0" rIns="0" bIns="0" rtlCol="0" anchor="ctr"/>
+          <a:lstStyle/>
           <a:p>
             <a:pPr indent="0" marL="0">
               <a:lnSpc>
-                <a:spcPct val="110000"/>
+                <a:spcPct val="115000"/>
               </a:lnSpc>
               <a:buNone/>
             </a:pPr>
             <a:r>
-              <a:rPr lang="en-US" sz="1050" b="1" dirty="0">
-                <a:solidFill>
-                  <a:srgbClr val="4B36C7"/>
-                </a:solidFill>
-                <a:latin typeface="Helvetica" pitchFamily="34" charset="0"/>
-                <a:ea typeface="Helvetica" pitchFamily="34" charset="-122"/>
-                <a:cs typeface="Helvetica" pitchFamily="34" charset="-120"/>
-              </a:rPr>
-              <a:t>panjang</a:t>
-            </a:r>
-            <a:endParaRPr lang="en-US" sz="1050" dirty="0"/>
-          </a:p>
-        </p:txBody>
-      </p:sp>
-      <p:sp>
-        <p:nvSpPr>
-          <p:cNvPr id="23" name="Shape 21"/>
-          <p:cNvSpPr/>
-          <p:nvPr/>
-        </p:nvSpPr>
-        <p:spPr>
-          <a:xfrm>
-            <a:off x="5715000" y="4078224"/>
-            <a:ext cx="2487168" cy="566928"/>
-          </a:xfrm>
-          <a:prstGeom prst="roundRect">
-            <a:avLst>
-              <a:gd name="adj" fmla="val 16129"/>
-            </a:avLst>
-          </a:prstGeom>
-          <a:solidFill>
-            <a:srgbClr val="F3F0FF"/>
-          </a:solidFill>
-          <a:ln w="12700">
-            <a:solidFill>
-              <a:srgbClr val="DCD3FB"/>
-            </a:solidFill>
-            <a:prstDash val="solid"/>
-          </a:ln>
-        </p:spPr>
-      </p:sp>
-      <p:sp>
-        <p:nvSpPr>
-          <p:cNvPr id="24" name="Text 22"/>
-          <p:cNvSpPr/>
-          <p:nvPr/>
-        </p:nvSpPr>
-        <p:spPr>
-          <a:xfrm>
-            <a:off x="5852160" y="4078224"/>
-            <a:ext cx="2212848" cy="566928"/>
-          </a:xfrm>
-          <a:prstGeom prst="rect">
-            <a:avLst/>
-          </a:prstGeom>
-          <a:noFill/>
-          <a:ln/>
-        </p:spPr>
-        <p:txBody>
-          <a:bodyPr wrap="square" lIns="0" tIns="0" rIns="0" bIns="0" rtlCol="0" anchor="ctr"/>
-          <a:lstStyle/>
-          <a:p>
-            <a:pPr indent="0" marL="0">
-              <a:lnSpc>
-                <a:spcPct val="110000"/>
-              </a:lnSpc>
-              <a:buNone/>
-            </a:pPr>
-            <a:r>
-              <a:rPr lang="en-US" sz="1050" b="1" dirty="0">
-                <a:solidFill>
-                  <a:srgbClr val="4B36C7"/>
-                </a:solidFill>
-                <a:latin typeface="Helvetica" pitchFamily="34" charset="0"/>
-                <a:ea typeface="Helvetica" pitchFamily="34" charset="-122"/>
-                <a:cs typeface="Helvetica" pitchFamily="34" charset="-120"/>
-              </a:rPr>
-              <a:t>Hashtag asal</a:t>
-            </a:r>
-            <a:endParaRPr lang="en-US" sz="1050" dirty="0"/>
-          </a:p>
-          <a:p>
-            <a:pPr indent="0" marL="0">
-              <a:lnSpc>
-                <a:spcPct val="110000"/>
-              </a:lnSpc>
-              <a:buNone/>
-            </a:pPr>
-            <a:r>
-              <a:rPr lang="en-US" sz="1050" b="1" dirty="0">
-                <a:solidFill>
-                  <a:srgbClr val="4B36C7"/>
-                </a:solidFill>
-                <a:latin typeface="Helvetica" pitchFamily="34" charset="0"/>
-                <a:ea typeface="Helvetica" pitchFamily="34" charset="-122"/>
-                <a:cs typeface="Helvetica" pitchFamily="34" charset="-120"/>
-              </a:rPr>
-              <a:t>tempel</a:t>
-            </a:r>
-            <a:endParaRPr lang="en-US" sz="1050" dirty="0"/>
-          </a:p>
-        </p:txBody>
-      </p:sp>
-      <p:sp>
-        <p:nvSpPr>
-          <p:cNvPr id="25" name="Shape 23"/>
-          <p:cNvSpPr/>
-          <p:nvPr/>
-        </p:nvSpPr>
-        <p:spPr>
-          <a:xfrm>
-            <a:off x="8321040" y="4078224"/>
-            <a:ext cx="2487168" cy="566928"/>
-          </a:xfrm>
-          <a:prstGeom prst="roundRect">
-            <a:avLst>
-              <a:gd name="adj" fmla="val 16129"/>
-            </a:avLst>
-          </a:prstGeom>
-          <a:solidFill>
-            <a:srgbClr val="F3F0FF"/>
-          </a:solidFill>
-          <a:ln w="12700">
-            <a:solidFill>
-              <a:srgbClr val="DCD3FB"/>
-            </a:solidFill>
-            <a:prstDash val="solid"/>
-          </a:ln>
-        </p:spPr>
-      </p:sp>
-      <p:sp>
-        <p:nvSpPr>
-          <p:cNvPr id="26" name="Text 24"/>
-          <p:cNvSpPr/>
-          <p:nvPr/>
-        </p:nvSpPr>
-        <p:spPr>
-          <a:xfrm>
-            <a:off x="8458200" y="4078224"/>
-            <a:ext cx="2212848" cy="566928"/>
-          </a:xfrm>
-          <a:prstGeom prst="rect">
-            <a:avLst/>
-          </a:prstGeom>
-          <a:noFill/>
-          <a:ln/>
-        </p:spPr>
-        <p:txBody>
-          <a:bodyPr wrap="square" lIns="0" tIns="0" rIns="0" bIns="0" rtlCol="0" anchor="ctr"/>
-          <a:lstStyle/>
-          <a:p>
-            <a:pPr indent="0" marL="0">
-              <a:lnSpc>
-                <a:spcPct val="110000"/>
-              </a:lnSpc>
-              <a:buNone/>
-            </a:pPr>
-            <a:r>
-              <a:rPr lang="en-US" sz="1050" b="1" dirty="0">
-                <a:solidFill>
-                  <a:srgbClr val="4B36C7"/>
-                </a:solidFill>
-                <a:latin typeface="Helvetica" pitchFamily="34" charset="0"/>
-                <a:ea typeface="Helvetica" pitchFamily="34" charset="-122"/>
-                <a:cs typeface="Helvetica" pitchFamily="34" charset="-120"/>
-              </a:rPr>
-              <a:t>Generate lalu</a:t>
-            </a:r>
-            <a:endParaRPr lang="en-US" sz="1050" dirty="0"/>
-          </a:p>
-          <a:p>
-            <a:pPr indent="0" marL="0">
-              <a:lnSpc>
-                <a:spcPct val="110000"/>
-              </a:lnSpc>
-              <a:buNone/>
-            </a:pPr>
-            <a:r>
-              <a:rPr lang="en-US" sz="1050" b="1" dirty="0">
-                <a:solidFill>
-                  <a:srgbClr val="4B36C7"/>
-                </a:solidFill>
-                <a:latin typeface="Helvetica" pitchFamily="34" charset="0"/>
-                <a:ea typeface="Helvetica" pitchFamily="34" charset="-122"/>
-                <a:cs typeface="Helvetica" pitchFamily="34" charset="-120"/>
-              </a:rPr>
-              <a:t>langsung post</a:t>
-            </a:r>
-            <a:endParaRPr lang="en-US" sz="1050" dirty="0"/>
-          </a:p>
-        </p:txBody>
-      </p:sp>
-      <p:sp>
-        <p:nvSpPr>
-          <p:cNvPr id="27" name="Shape 25"/>
-          <p:cNvSpPr/>
-          <p:nvPr/>
-        </p:nvSpPr>
-        <p:spPr>
-          <a:xfrm>
-            <a:off x="502920" y="4873752"/>
-            <a:ext cx="11064240" cy="1005840"/>
-          </a:xfrm>
-          <a:prstGeom prst="roundRect">
-            <a:avLst>
-              <a:gd name="adj" fmla="val 9091"/>
-            </a:avLst>
-          </a:prstGeom>
-          <a:solidFill>
-            <a:srgbClr val="F3F0FF"/>
-          </a:solidFill>
-          <a:ln w="12700">
-            <a:solidFill>
-              <a:srgbClr val="DCD3FB"/>
-            </a:solidFill>
-            <a:prstDash val="solid"/>
-          </a:ln>
-        </p:spPr>
-      </p:sp>
-      <p:sp>
-        <p:nvSpPr>
-          <p:cNvPr id="28" name="Text 26"/>
-          <p:cNvSpPr/>
-          <p:nvPr/>
-        </p:nvSpPr>
-        <p:spPr>
-          <a:xfrm>
-            <a:off x="713232" y="4873752"/>
-            <a:ext cx="10643616" cy="1005840"/>
-          </a:xfrm>
-          <a:prstGeom prst="rect">
-            <a:avLst/>
-          </a:prstGeom>
-          <a:noFill/>
-          <a:ln/>
-        </p:spPr>
-        <p:txBody>
-          <a:bodyPr wrap="square" lIns="0" tIns="0" rIns="0" bIns="0" rtlCol="0" anchor="ctr"/>
-          <a:lstStyle/>
-          <a:p>
-            <a:pPr indent="0" marL="0">
-              <a:lnSpc>
-                <a:spcPct val="125000"/>
-              </a:lnSpc>
-              <a:buNone/>
-            </a:pPr>
-            <a:r>
-              <a:rPr lang="en-US" sz="1200" b="1" dirty="0">
-                <a:solidFill>
-                  <a:srgbClr val="4B36C7"/>
-                </a:solidFill>
-                <a:latin typeface="Helvetica" pitchFamily="34" charset="0"/>
-                <a:ea typeface="Helvetica" pitchFamily="34" charset="-122"/>
-                <a:cs typeface="Helvetica" pitchFamily="34" charset="-120"/>
-              </a:rPr>
-              <a:t>◆  YANG KAMU BUTUHKAN  </a:t>
-            </a:r>
-            <a:pPr indent="0" marL="0">
-              <a:lnSpc>
-                <a:spcPct val="125000"/>
-              </a:lnSpc>
-              <a:buNone/>
-            </a:pPr>
-            <a:r>
-              <a:rPr lang="en-US" sz="1200" dirty="0">
-                <a:solidFill>
-                  <a:srgbClr val="23283A"/>
-                </a:solidFill>
-                <a:latin typeface="Helvetica" pitchFamily="34" charset="0"/>
-                <a:ea typeface="Helvetica" pitchFamily="34" charset="-122"/>
-                <a:cs typeface="Helvetica" pitchFamily="34" charset="-120"/>
-              </a:rPr>
-              <a:t>file cm-kalender-konten.csv (template 16 slot posting per bulan), akun Instagram bisnis aktif + 5-10 foto produk, dan Canva Connector aktif (opsional). Positioning dan katalog produk dari Modul 1-2 sudah otomatis tersedia kalau kamu masih di Project yang sama.</a:t>
-            </a:r>
-            <a:endParaRPr lang="en-US" sz="1200" dirty="0"/>
+              <a:rPr lang="en-US" sz="1100" dirty="0">
+                <a:solidFill>
+                  <a:srgbClr val="7A3B3B"/>
+                </a:solidFill>
+                <a:latin typeface="Helvetica" pitchFamily="34" charset="0"/>
+                <a:ea typeface="Helvetica" pitchFamily="34" charset="-122"/>
+                <a:cs typeface="Helvetica" pitchFamily="34" charset="-120"/>
+              </a:rPr>
+              <a:t>Generate lalu langsung post — Claude tidak tahu promo yang baru berubah atau stok habis</a:t>
+            </a:r>
+            <a:endParaRPr lang="en-US" sz="1100" dirty="0"/>
           </a:p>
         </p:txBody>
       </p:sp>
@@ -3861,12 +3770,12 @@
         </p:nvSpPr>
         <p:spPr>
           <a:xfrm>
-            <a:off x="502920" y="2148840"/>
-            <a:ext cx="5166360" cy="1783080"/>
+            <a:off x="502920" y="2121408"/>
+            <a:ext cx="5166360" cy="1691640"/>
           </a:xfrm>
           <a:prstGeom prst="roundRect">
             <a:avLst>
-              <a:gd name="adj" fmla="val 6154"/>
+              <a:gd name="adj" fmla="val 6486"/>
             </a:avLst>
           </a:prstGeom>
           <a:solidFill>
@@ -3888,7 +3797,7 @@
         </p:nvSpPr>
         <p:spPr>
           <a:xfrm>
-            <a:off x="704088" y="2350008"/>
+            <a:off x="704088" y="2322576"/>
             <a:ext cx="4764024" cy="274320"/>
           </a:xfrm>
           <a:prstGeom prst="rect">
@@ -3927,7 +3836,7 @@
         </p:nvSpPr>
         <p:spPr>
           <a:xfrm>
-            <a:off x="704088" y="2715768"/>
+            <a:off x="704088" y="2688336"/>
             <a:ext cx="4764024" cy="365760"/>
           </a:xfrm>
           <a:prstGeom prst="rect">
@@ -3969,7 +3878,7 @@
         </p:nvSpPr>
         <p:spPr>
           <a:xfrm>
-            <a:off x="704088" y="3246120"/>
+            <a:off x="704088" y="3172968"/>
             <a:ext cx="4764024" cy="457200"/>
           </a:xfrm>
           <a:prstGeom prst="rect">
@@ -4011,12 +3920,12 @@
         </p:nvSpPr>
         <p:spPr>
           <a:xfrm>
-            <a:off x="6172200" y="2148840"/>
-            <a:ext cx="5166360" cy="2331720"/>
+            <a:off x="6172200" y="2121408"/>
+            <a:ext cx="5166360" cy="2286000"/>
           </a:xfrm>
           <a:prstGeom prst="roundRect">
             <a:avLst>
-              <a:gd name="adj" fmla="val 4706"/>
+              <a:gd name="adj" fmla="val 4800"/>
             </a:avLst>
           </a:prstGeom>
           <a:solidFill>
@@ -4038,7 +3947,7 @@
         </p:nvSpPr>
         <p:spPr>
           <a:xfrm>
-            <a:off x="6373368" y="2350008"/>
+            <a:off x="6373368" y="2322576"/>
             <a:ext cx="4764024" cy="274320"/>
           </a:xfrm>
           <a:prstGeom prst="rect">
@@ -4077,7 +3986,7 @@
         </p:nvSpPr>
         <p:spPr>
           <a:xfrm>
-            <a:off x="6373368" y="2697480"/>
+            <a:off x="6373368" y="2670048"/>
             <a:ext cx="4764024" cy="1280160"/>
           </a:xfrm>
           <a:prstGeom prst="rect">
@@ -4119,8 +4028,8 @@
         </p:nvSpPr>
         <p:spPr>
           <a:xfrm>
-            <a:off x="6373368" y="4023360"/>
-            <a:ext cx="4764024" cy="411480"/>
+            <a:off x="6373368" y="3904488"/>
+            <a:ext cx="4764024" cy="457200"/>
           </a:xfrm>
           <a:prstGeom prst="rect">
             <a:avLst/>
@@ -4150,6 +4059,92 @@
               <a:t>Kenapa berhasil: 1 prompt = 16 caption terstruktur siap isi ke kalender.</a:t>
             </a:r>
             <a:endParaRPr lang="en-US" sz="1150" dirty="0"/>
+          </a:p>
+        </p:txBody>
+      </p:sp>
+      <p:sp>
+        <p:nvSpPr>
+          <p:cNvPr id="16" name="Shape 14"/>
+          <p:cNvSpPr/>
+          <p:nvPr/>
+        </p:nvSpPr>
+        <p:spPr>
+          <a:xfrm>
+            <a:off x="502920" y="4590288"/>
+            <a:ext cx="11064240" cy="1097280"/>
+          </a:xfrm>
+          <a:prstGeom prst="roundRect">
+            <a:avLst>
+              <a:gd name="adj" fmla="val 8333"/>
+            </a:avLst>
+          </a:prstGeom>
+          <a:solidFill>
+            <a:srgbClr val="F3F0FF"/>
+          </a:solidFill>
+          <a:ln w="12700">
+            <a:solidFill>
+              <a:srgbClr val="DCD3FB"/>
+            </a:solidFill>
+            <a:prstDash val="solid"/>
+          </a:ln>
+        </p:spPr>
+      </p:sp>
+      <p:sp>
+        <p:nvSpPr>
+          <p:cNvPr id="17" name="Text 15"/>
+          <p:cNvSpPr/>
+          <p:nvPr/>
+        </p:nvSpPr>
+        <p:spPr>
+          <a:xfrm>
+            <a:off x="713232" y="4590288"/>
+            <a:ext cx="10643616" cy="1097280"/>
+          </a:xfrm>
+          <a:prstGeom prst="rect">
+            <a:avLst/>
+          </a:prstGeom>
+          <a:noFill/>
+          <a:ln/>
+        </p:spPr>
+        <p:txBody>
+          <a:bodyPr wrap="square" lIns="0" tIns="0" rIns="0" bIns="0" rtlCol="0" anchor="ctr"/>
+          <a:lstStyle/>
+          <a:p>
+            <a:pPr indent="0" marL="0">
+              <a:lnSpc>
+                <a:spcPct val="125000"/>
+              </a:lnSpc>
+              <a:buNone/>
+            </a:pPr>
+            <a:r>
+              <a:rPr lang="en-US" sz="1200" b="1" dirty="0">
+                <a:solidFill>
+                  <a:srgbClr val="4B36C7"/>
+                </a:solidFill>
+                <a:latin typeface="Helvetica" pitchFamily="34" charset="0"/>
+                <a:ea typeface="Helvetica" pitchFamily="34" charset="-122"/>
+                <a:cs typeface="Helvetica" pitchFamily="34" charset="-120"/>
+              </a:rPr>
+              <a:t>◆  YANG KAMU BUTUHKAN  </a:t>
+            </a:r>
+            <a:pPr indent="0" marL="0">
+              <a:lnSpc>
+                <a:spcPct val="125000"/>
+              </a:lnSpc>
+              <a:buNone/>
+            </a:pPr>
+            <a:r>
+              <a:rPr lang="en-US" sz="1200" dirty="0">
+                <a:solidFill>
+                  <a:srgbClr val="23283A"/>
+                </a:solidFill>
+                <a:latin typeface="Helvetica" pitchFamily="34" charset="0"/>
+                <a:ea typeface="Helvetica" pitchFamily="34" charset="-122"/>
+                <a:cs typeface="Helvetica" pitchFamily="34" charset="-120"/>
+              </a:rPr>
+              <a:t>file cm-kalender-konten.csv (template 16 slot posting per bulan), akun Instagram bisnis aktif + 5-10 foto produk, dan Canva Connector aktif (opsional). Positioning dan katalog produk dari Modul 1-2 sudah otomatis tersedia kalau kamu masih di Project yang sama.</a:t>
+            </a:r>
+            <a:endParaRPr lang="en-US" sz="1200" dirty="0"/>
           </a:p>
         </p:txBody>
       </p:sp>
@@ -4382,7 +4377,7 @@
                 <a:ea typeface="Helvetica" pitchFamily="34" charset="-122"/>
                 <a:cs typeface="Helvetica" pitchFamily="34" charset="-120"/>
               </a:rPr>
-              <a:t>Cara Kerja: 5 Langkah</a:t>
+              <a:t>Cara Kerja</a:t>
             </a:r>
             <a:endParaRPr lang="en-US" sz="2200" dirty="0"/>
           </a:p>
@@ -4396,7 +4391,7 @@
         </p:nvSpPr>
         <p:spPr>
           <a:xfrm>
-            <a:off x="548640" y="2121408"/>
+            <a:off x="548640" y="2194560"/>
             <a:ext cx="329184" cy="329184"/>
           </a:xfrm>
           <a:prstGeom prst="ellipse">
@@ -4416,7 +4411,7 @@
         </p:nvSpPr>
         <p:spPr>
           <a:xfrm>
-            <a:off x="548640" y="2121408"/>
+            <a:off x="548640" y="2194560"/>
             <a:ext cx="329184" cy="329184"/>
           </a:xfrm>
           <a:prstGeom prst="rect">
@@ -4455,20 +4450,23 @@
         </p:nvSpPr>
         <p:spPr>
           <a:xfrm>
-            <a:off x="1024128" y="2093976"/>
-            <a:ext cx="10607040" cy="457200"/>
-          </a:xfrm>
-          <a:prstGeom prst="rect">
-            <a:avLst/>
-          </a:prstGeom>
-          <a:noFill/>
-          <a:ln/>
-        </p:spPr>
-        <p:txBody>
-          <a:bodyPr wrap="square" lIns="0" tIns="0" rIns="0" bIns="0" rtlCol="0" anchor="ctr"/>
-          <a:lstStyle/>
-          <a:p>
-            <a:pPr indent="0" marL="0">
+            <a:off x="1024128" y="2148840"/>
+            <a:ext cx="10607040" cy="548640"/>
+          </a:xfrm>
+          <a:prstGeom prst="rect">
+            <a:avLst/>
+          </a:prstGeom>
+          <a:noFill/>
+          <a:ln/>
+        </p:spPr>
+        <p:txBody>
+          <a:bodyPr wrap="square" lIns="0" tIns="0" rIns="0" bIns="0" rtlCol="0" anchor="ctr"/>
+          <a:lstStyle/>
+          <a:p>
+            <a:pPr indent="0" marL="0">
+              <a:lnSpc>
+                <a:spcPct val="120000"/>
+              </a:lnSpc>
               <a:buNone/>
             </a:pPr>
             <a:r>
@@ -4483,6 +4481,9 @@
               <a:t>Siapkan Bahan Tambahan — </a:t>
             </a:r>
             <a:pPr indent="0" marL="0">
+              <a:lnSpc>
+                <a:spcPct val="120000"/>
+              </a:lnSpc>
               <a:buNone/>
             </a:pPr>
             <a:r>
@@ -4508,7 +4509,7 @@
         </p:nvSpPr>
         <p:spPr>
           <a:xfrm>
-            <a:off x="548640" y="2651760"/>
+            <a:off x="548640" y="2816352"/>
             <a:ext cx="329184" cy="329184"/>
           </a:xfrm>
           <a:prstGeom prst="ellipse">
@@ -4528,7 +4529,7 @@
         </p:nvSpPr>
         <p:spPr>
           <a:xfrm>
-            <a:off x="548640" y="2651760"/>
+            <a:off x="548640" y="2816352"/>
             <a:ext cx="329184" cy="329184"/>
           </a:xfrm>
           <a:prstGeom prst="rect">
@@ -4567,20 +4568,23 @@
         </p:nvSpPr>
         <p:spPr>
           <a:xfrm>
-            <a:off x="1024128" y="2624328"/>
-            <a:ext cx="10607040" cy="457200"/>
-          </a:xfrm>
-          <a:prstGeom prst="rect">
-            <a:avLst/>
-          </a:prstGeom>
-          <a:noFill/>
-          <a:ln/>
-        </p:spPr>
-        <p:txBody>
-          <a:bodyPr wrap="square" lIns="0" tIns="0" rIns="0" bIns="0" rtlCol="0" anchor="ctr"/>
-          <a:lstStyle/>
-          <a:p>
-            <a:pPr indent="0" marL="0">
+            <a:off x="1024128" y="2770632"/>
+            <a:ext cx="10607040" cy="548640"/>
+          </a:xfrm>
+          <a:prstGeom prst="rect">
+            <a:avLst/>
+          </a:prstGeom>
+          <a:noFill/>
+          <a:ln/>
+        </p:spPr>
+        <p:txBody>
+          <a:bodyPr wrap="square" lIns="0" tIns="0" rIns="0" bIns="0" rtlCol="0" anchor="ctr"/>
+          <a:lstStyle/>
+          <a:p>
+            <a:pPr indent="0" marL="0">
+              <a:lnSpc>
+                <a:spcPct val="120000"/>
+              </a:lnSpc>
               <a:buNone/>
             </a:pPr>
             <a:r>
@@ -4595,6 +4599,9 @@
               <a:t>Generate Kalender 30 Hari — </a:t>
             </a:r>
             <a:pPr indent="0" marL="0">
+              <a:lnSpc>
+                <a:spcPct val="120000"/>
+              </a:lnSpc>
               <a:buNone/>
             </a:pPr>
             <a:r>
@@ -4620,7 +4627,7 @@
         </p:nvSpPr>
         <p:spPr>
           <a:xfrm>
-            <a:off x="548640" y="3182112"/>
+            <a:off x="548640" y="3438144"/>
             <a:ext cx="329184" cy="329184"/>
           </a:xfrm>
           <a:prstGeom prst="ellipse">
@@ -4640,7 +4647,7 @@
         </p:nvSpPr>
         <p:spPr>
           <a:xfrm>
-            <a:off x="548640" y="3182112"/>
+            <a:off x="548640" y="3438144"/>
             <a:ext cx="329184" cy="329184"/>
           </a:xfrm>
           <a:prstGeom prst="rect">
@@ -4679,20 +4686,23 @@
         </p:nvSpPr>
         <p:spPr>
           <a:xfrm>
-            <a:off x="1024128" y="3154680"/>
-            <a:ext cx="10607040" cy="457200"/>
-          </a:xfrm>
-          <a:prstGeom prst="rect">
-            <a:avLst/>
-          </a:prstGeom>
-          <a:noFill/>
-          <a:ln/>
-        </p:spPr>
-        <p:txBody>
-          <a:bodyPr wrap="square" lIns="0" tIns="0" rIns="0" bIns="0" rtlCol="0" anchor="ctr"/>
-          <a:lstStyle/>
-          <a:p>
-            <a:pPr indent="0" marL="0">
+            <a:off x="1024128" y="3392424"/>
+            <a:ext cx="10607040" cy="548640"/>
+          </a:xfrm>
+          <a:prstGeom prst="rect">
+            <a:avLst/>
+          </a:prstGeom>
+          <a:noFill/>
+          <a:ln/>
+        </p:spPr>
+        <p:txBody>
+          <a:bodyPr wrap="square" lIns="0" tIns="0" rIns="0" bIns="0" rtlCol="0" anchor="ctr"/>
+          <a:lstStyle/>
+          <a:p>
+            <a:pPr indent="0" marL="0">
+              <a:lnSpc>
+                <a:spcPct val="120000"/>
+              </a:lnSpc>
               <a:buNone/>
             </a:pPr>
             <a:r>
@@ -4707,6 +4717,9 @@
               <a:t>Review &amp; Personalisasi — </a:t>
             </a:r>
             <a:pPr indent="0" marL="0">
+              <a:lnSpc>
+                <a:spcPct val="120000"/>
+              </a:lnSpc>
               <a:buNone/>
             </a:pPr>
             <a:r>
@@ -4732,7 +4745,7 @@
         </p:nvSpPr>
         <p:spPr>
           <a:xfrm>
-            <a:off x="548640" y="3712464"/>
+            <a:off x="548640" y="4059936"/>
             <a:ext cx="329184" cy="329184"/>
           </a:xfrm>
           <a:prstGeom prst="ellipse">
@@ -4752,7 +4765,7 @@
         </p:nvSpPr>
         <p:spPr>
           <a:xfrm>
-            <a:off x="548640" y="3712464"/>
+            <a:off x="548640" y="4059936"/>
             <a:ext cx="329184" cy="329184"/>
           </a:xfrm>
           <a:prstGeom prst="rect">
@@ -4791,20 +4804,23 @@
         </p:nvSpPr>
         <p:spPr>
           <a:xfrm>
-            <a:off x="1024128" y="3685032"/>
-            <a:ext cx="10607040" cy="457200"/>
-          </a:xfrm>
-          <a:prstGeom prst="rect">
-            <a:avLst/>
-          </a:prstGeom>
-          <a:noFill/>
-          <a:ln/>
-        </p:spPr>
-        <p:txBody>
-          <a:bodyPr wrap="square" lIns="0" tIns="0" rIns="0" bIns="0" rtlCol="0" anchor="ctr"/>
-          <a:lstStyle/>
-          <a:p>
-            <a:pPr indent="0" marL="0">
+            <a:off x="1024128" y="4014216"/>
+            <a:ext cx="10607040" cy="548640"/>
+          </a:xfrm>
+          <a:prstGeom prst="rect">
+            <a:avLst/>
+          </a:prstGeom>
+          <a:noFill/>
+          <a:ln/>
+        </p:spPr>
+        <p:txBody>
+          <a:bodyPr wrap="square" lIns="0" tIns="0" rIns="0" bIns="0" rtlCol="0" anchor="ctr"/>
+          <a:lstStyle/>
+          <a:p>
+            <a:pPr indent="0" marL="0">
+              <a:lnSpc>
+                <a:spcPct val="120000"/>
+              </a:lnSpc>
               <a:buNone/>
             </a:pPr>
             <a:r>
@@ -4819,6 +4835,9 @@
               <a:t>Import — </a:t>
             </a:r>
             <a:pPr indent="0" marL="0">
+              <a:lnSpc>
+                <a:spcPct val="120000"/>
+              </a:lnSpc>
               <a:buNone/>
             </a:pPr>
             <a:r>
@@ -4844,124 +4863,12 @@
         </p:nvSpPr>
         <p:spPr>
           <a:xfrm>
-            <a:off x="548640" y="4242816"/>
-            <a:ext cx="329184" cy="329184"/>
-          </a:xfrm>
-          <a:prstGeom prst="ellipse">
-            <a:avLst/>
-          </a:prstGeom>
-          <a:solidFill>
-            <a:srgbClr val="6849F6"/>
-          </a:solidFill>
-          <a:ln/>
-        </p:spPr>
-      </p:sp>
-      <p:sp>
-        <p:nvSpPr>
-          <p:cNvPr id="21" name="Text 19"/>
-          <p:cNvSpPr/>
-          <p:nvPr/>
-        </p:nvSpPr>
-        <p:spPr>
-          <a:xfrm>
-            <a:off x="548640" y="4242816"/>
-            <a:ext cx="329184" cy="329184"/>
-          </a:xfrm>
-          <a:prstGeom prst="rect">
-            <a:avLst/>
-          </a:prstGeom>
-          <a:noFill/>
-          <a:ln/>
-        </p:spPr>
-        <p:txBody>
-          <a:bodyPr wrap="square" lIns="0" tIns="0" rIns="0" bIns="0" rtlCol="0" anchor="ctr"/>
-          <a:lstStyle/>
-          <a:p>
-            <a:pPr algn="ctr" indent="0" marL="0">
-              <a:buNone/>
-            </a:pPr>
-            <a:r>
-              <a:rPr lang="en-US" sz="1300" b="1" dirty="0">
-                <a:solidFill>
-                  <a:srgbClr val="FFFFFF"/>
-                </a:solidFill>
-                <a:latin typeface="Helvetica" pitchFamily="34" charset="0"/>
-                <a:ea typeface="Helvetica" pitchFamily="34" charset="-122"/>
-                <a:cs typeface="Helvetica" pitchFamily="34" charset="-120"/>
-              </a:rPr>
-              <a:t>5</a:t>
-            </a:r>
-            <a:endParaRPr lang="en-US" sz="1300" dirty="0"/>
-          </a:p>
-        </p:txBody>
-      </p:sp>
-      <p:sp>
-        <p:nvSpPr>
-          <p:cNvPr id="22" name="Text 20"/>
-          <p:cNvSpPr/>
-          <p:nvPr/>
-        </p:nvSpPr>
-        <p:spPr>
-          <a:xfrm>
-            <a:off x="1024128" y="4215384"/>
-            <a:ext cx="10607040" cy="457200"/>
-          </a:xfrm>
-          <a:prstGeom prst="rect">
-            <a:avLst/>
-          </a:prstGeom>
-          <a:noFill/>
-          <a:ln/>
-        </p:spPr>
-        <p:txBody>
-          <a:bodyPr wrap="square" lIns="0" tIns="0" rIns="0" bIns="0" rtlCol="0" anchor="ctr"/>
-          <a:lstStyle/>
-          <a:p>
-            <a:pPr indent="0" marL="0">
-              <a:buNone/>
-            </a:pPr>
-            <a:r>
-              <a:rPr lang="en-US" sz="1300" b="1" dirty="0">
-                <a:solidFill>
-                  <a:srgbClr val="0D1321"/>
-                </a:solidFill>
-                <a:latin typeface="Helvetica" pitchFamily="34" charset="0"/>
-                <a:ea typeface="Helvetica" pitchFamily="34" charset="-122"/>
-                <a:cs typeface="Helvetica" pitchFamily="34" charset="-120"/>
-              </a:rPr>
-              <a:t>Ulangi Tiap Awal Bulan — </a:t>
-            </a:r>
-            <a:pPr indent="0" marL="0">
-              <a:buNone/>
-            </a:pPr>
-            <a:r>
-              <a:rPr lang="en-US" sz="1300" dirty="0">
-                <a:solidFill>
-                  <a:srgbClr val="23283A"/>
-                </a:solidFill>
-                <a:latin typeface="Helvetica" pitchFamily="34" charset="0"/>
-                <a:ea typeface="Helvetica" pitchFamily="34" charset="-122"/>
-                <a:cs typeface="Helvetica" pitchFamily="34" charset="-120"/>
-              </a:rPr>
-              <a:t>simpan prompt terbaik sebagai template</a:t>
-            </a:r>
-            <a:endParaRPr lang="en-US" sz="1300" dirty="0"/>
-          </a:p>
-        </p:txBody>
-      </p:sp>
-      <p:sp>
-        <p:nvSpPr>
-          <p:cNvPr id="23" name="Shape 21"/>
-          <p:cNvSpPr/>
-          <p:nvPr/>
-        </p:nvSpPr>
-        <p:spPr>
-          <a:xfrm>
-            <a:off x="502920" y="4937760"/>
-            <a:ext cx="11064240" cy="868680"/>
+            <a:off x="502920" y="4818888"/>
+            <a:ext cx="11064240" cy="960120"/>
           </a:xfrm>
           <a:prstGeom prst="roundRect">
             <a:avLst>
-              <a:gd name="adj" fmla="val 10526"/>
+              <a:gd name="adj" fmla="val 9524"/>
             </a:avLst>
           </a:prstGeom>
           <a:solidFill>
@@ -4977,14 +4884,14 @@
       </p:sp>
       <p:sp>
         <p:nvSpPr>
-          <p:cNvPr id="24" name="Text 22"/>
-          <p:cNvSpPr/>
-          <p:nvPr/>
-        </p:nvSpPr>
-        <p:spPr>
-          <a:xfrm>
-            <a:off x="713232" y="4937760"/>
-            <a:ext cx="10643616" cy="868680"/>
+          <p:cNvPr id="21" name="Text 19"/>
+          <p:cNvSpPr/>
+          <p:nvPr/>
+        </p:nvSpPr>
+        <p:spPr>
+          <a:xfrm>
+            <a:off x="713232" y="4818888"/>
+            <a:ext cx="10643616" cy="960120"/>
           </a:xfrm>
           <a:prstGeom prst="rect">
             <a:avLst/>
@@ -6191,11 +6098,11 @@
         <p:spPr>
           <a:xfrm>
             <a:off x="502920" y="4279392"/>
-            <a:ext cx="11064240" cy="1691640"/>
+            <a:ext cx="11064240" cy="1737360"/>
           </a:xfrm>
           <a:prstGeom prst="roundRect">
             <a:avLst>
-              <a:gd name="adj" fmla="val 6486"/>
+              <a:gd name="adj" fmla="val 6316"/>
             </a:avLst>
           </a:prstGeom>
           <a:solidFill>
@@ -6252,7 +6159,7 @@
         <p:spPr>
           <a:xfrm>
             <a:off x="713232" y="4736592"/>
-            <a:ext cx="10607040" cy="1188720"/>
+            <a:ext cx="10607040" cy="1234440"/>
           </a:xfrm>
           <a:prstGeom prst="rect">
             <a:avLst/>
@@ -6299,7 +6206,7 @@
                 <a:ea typeface="Helvetica" pitchFamily="34" charset="-122"/>
                 <a:cs typeface="Helvetica" pitchFamily="34" charset="-120"/>
               </a:rPr>
-              <a:t>File pendukung: cm-kalender-konten.csv. Bonus: 1 dashboard HTML, 1 grafis Claude, 1 foto produk via Prompt Enhancer.</a:t>
+              <a:t>File pendukung: cm-kalender-konten.csv. Bonus: 1 dashboard HTML, 1 grafis Claude, 1 foto produk via Prompt Enhancer. Ulangi tiap awal bulan — simpan prompt terbaik sebagai template.</a:t>
             </a:r>
             <a:endParaRPr lang="en-US" sz="1200" dirty="0"/>
           </a:p>

</xml_diff>

<commit_message>
M03 PPTX: add multi-platform note, sync xlsx filename references
- New note box on slide 3 (cloned from slide 2's CATATAN style): the
  content-calendar system isn't Instagram-exclusive, works for TikTok/
  Facebook too with format adjustments -- matches the HTML tip-box added
  in 765792e.
- Slide 2 'FORMAT OUTPUT CSV' card updated to 'TEMPLATE SPREADSHEET SIAP
  PAKAI' matching the HTML info-card rewrite.
- 3 stray cm-kalender-konten.csv mentions (slides 4 and 7) updated to
  .xlsx, matching the Checkpoint 81 file swap.
- Validated with office/validate.py (all passed) and a full visual QA
  pass on all 4 touched slides.
</commit_message>
<xml_diff>
--- a/Content-Marketing/M03-Konten-Instagram/K3-M03-Sistem-Konten-Instagram.pptx
+++ b/Content-Marketing/M03-Konten-Instagram/K3-M03-Sistem-Konten-Instagram.pptx
@@ -2183,7 +2183,7 @@
                 <a:ea typeface="Helvetica" pitchFamily="34" charset="-122"/>
                 <a:cs typeface="Helvetica" pitchFamily="34" charset="-120"/>
               </a:rPr>
-              <a:t>FORMAT OUTPUT CSV</a:t>
+              <a:t>TEMPLATE SPREADSHEET SIAP PAKAI</a:t>
             </a:r>
             <a:endParaRPr lang="en-US" sz="1150" dirty="0"/>
           </a:p>
@@ -2225,7 +2225,7 @@
                 <a:ea typeface="Helvetica" pitchFamily="34" charset="-122"/>
                 <a:cs typeface="Helvetica" pitchFamily="34" charset="-120"/>
               </a:rPr>
-              <a:t>Langsung import ke Google Sheets atau tool scheduling</a:t>
+              <a:t>Warna otomatis per tema, dropdown status, ringkasan real-time.</a:t>
             </a:r>
             <a:endParaRPr lang="en-US" sz="1100" dirty="0"/>
           </a:p>
@@ -3527,6 +3527,92 @@
           </a:p>
         </p:txBody>
       </p:sp>
+      <p:sp>
+        <p:nvSpPr>
+          <p:cNvPr id="28" name="Shape 26"/>
+          <p:cNvSpPr/>
+          <p:nvPr/>
+        </p:nvSpPr>
+        <p:spPr>
+          <a:xfrm>
+            <a:off x="502920" y="5560000"/>
+            <a:ext cx="11064240" cy="750000"/>
+          </a:xfrm>
+          <a:prstGeom prst="roundRect">
+            <a:avLst>
+              <a:gd name="adj" fmla="val 15385"/>
+            </a:avLst>
+          </a:prstGeom>
+          <a:solidFill>
+            <a:srgbClr val="F4F6FB"/>
+          </a:solidFill>
+          <a:ln w="12700">
+            <a:solidFill>
+              <a:srgbClr val="D6DCEB"/>
+            </a:solidFill>
+            <a:prstDash val="solid"/>
+          </a:ln>
+        </p:spPr>
+      </p:sp>
+      <p:sp>
+        <p:nvSpPr>
+          <p:cNvPr id="29" name="Text 27"/>
+          <p:cNvSpPr/>
+          <p:nvPr/>
+        </p:nvSpPr>
+        <p:spPr>
+          <a:xfrm>
+            <a:off x="713232" y="5560000"/>
+            <a:ext cx="10643616" cy="750000"/>
+          </a:xfrm>
+          <a:prstGeom prst="rect">
+            <a:avLst/>
+          </a:prstGeom>
+          <a:noFill/>
+          <a:ln/>
+        </p:spPr>
+        <p:txBody>
+          <a:bodyPr wrap="square" lIns="0" tIns="0" rIns="0" bIns="0" rtlCol="0" anchor="ctr"/>
+          <a:lstStyle/>
+          <a:p>
+            <a:pPr indent="0" marL="0">
+              <a:lnSpc>
+                <a:spcPct val="120000"/>
+              </a:lnSpc>
+              <a:buNone/>
+            </a:pPr>
+            <a:r>
+              <a:rPr lang="en-US" sz="1150" b="1" dirty="0">
+                <a:solidFill>
+                  <a:srgbClr val="6B7280"/>
+                </a:solidFill>
+                <a:latin typeface="Helvetica" pitchFamily="34" charset="0"/>
+                <a:ea typeface="Helvetica" pitchFamily="34" charset="-122"/>
+                <a:cs typeface="Helvetica" pitchFamily="34" charset="-120"/>
+              </a:rPr>
+              <a:t>◆  BUKAN CUMA UNTUK INSTAGRAM  </a:t>
+            </a:r>
+            <a:pPr indent="0" marL="0">
+              <a:lnSpc>
+                <a:spcPct val="120000"/>
+              </a:lnSpc>
+              <a:buNone/>
+            </a:pPr>
+            <a:r>
+              <a:rPr lang="en-US" sz="1150" dirty="0">
+                <a:solidFill>
+                  <a:srgbClr val="6B7280"/>
+                </a:solidFill>
+                <a:latin typeface="Helvetica" pitchFamily="34" charset="0"/>
+                <a:ea typeface="Helvetica" pitchFamily="34" charset="-122"/>
+                <a:cs typeface="Helvetica" pitchFamily="34" charset="-120"/>
+              </a:rPr>
+              <a:t>Sistem kalender &amp; framework Hook-Value-CTA ini juga berlaku untuk TikTok, Facebook, atau platform lain — tinggal minta Claude sesuaikan formatnya per platform.</a:t>
+            </a:r>
+            <a:endParaRPr lang="en-US" sz="1150" dirty="0"/>
+          </a:p>
+        </p:txBody>
+      </p:sp>
     </p:spTree>
   </p:cSld>
   <p:clrMapOvr>
@@ -4142,7 +4228,7 @@
                 <a:ea typeface="Helvetica" pitchFamily="34" charset="-122"/>
                 <a:cs typeface="Helvetica" pitchFamily="34" charset="-120"/>
               </a:rPr>
-              <a:t>file cm-kalender-konten.csv (template 16 slot posting per bulan), akun Instagram bisnis aktif + 5-10 foto produk, dan Canva Connector aktif (opsional). Positioning dan katalog produk dari Modul 1-2 sudah otomatis tersedia kalau kamu masih di Project yang sama.</a:t>
+              <a:t>file cm-kalender-konten.xlsx (template 16 slot posting per bulan), akun Instagram bisnis aktif + 5-10 foto produk, dan Canva Connector aktif (opsional). Positioning dan katalog produk dari Modul 1-2 sudah otomatis tersedia kalau kamu masih di Project yang sama.</a:t>
             </a:r>
             <a:endParaRPr lang="en-US" sz="1200" dirty="0"/>
           </a:p>
@@ -6014,7 +6100,7 @@
                 <a:ea typeface="Helvetica" pitchFamily="34" charset="-122"/>
                 <a:cs typeface="Helvetica" pitchFamily="34" charset="-120"/>
               </a:rPr>
-              <a:t>Jalankan prompt ini untuk bulan depan, lalu isi hasilnya ke cm-kalender-konten.csv. Pilih 3 caption terbaik, personalisasi, dan jadwalkan. Bonus: minta Claude ubah jadi dashboard HTML, buat 1 grafis, dan 1 foto produk dengan Prompt Enhancer.</a:t>
+              <a:t>Jalankan prompt ini untuk bulan depan, lalu isi hasilnya ke cm-kalender-konten.xlsx. Pilih 3 caption terbaik, personalisasi, dan jadwalkan. Bonus: minta Claude ubah jadi dashboard HTML, buat 1 grafis, dan 1 foto produk dengan Prompt Enhancer.</a:t>
             </a:r>
             <a:endParaRPr lang="en-US" sz="1200" dirty="0"/>
           </a:p>
@@ -6206,7 +6292,7 @@
                 <a:ea typeface="Helvetica" pitchFamily="34" charset="-122"/>
                 <a:cs typeface="Helvetica" pitchFamily="34" charset="-120"/>
               </a:rPr>
-              <a:t>File pendukung: cm-kalender-konten.csv. Bonus: 1 dashboard HTML, 1 grafis Claude, 1 foto produk via Prompt Enhancer. Ulangi tiap awal bulan — simpan prompt terbaik sebagai template.</a:t>
+              <a:t>File pendukung: cm-kalender-konten.xlsx. Bonus: 1 dashboard HTML, 1 grafis Claude, 1 foto produk via Prompt Enhancer. Ulangi tiap awal bulan — simpan prompt terbaik sebagai template.</a:t>
             </a:r>
             <a:endParaRPr lang="en-US" sz="1200" dirty="0"/>
           </a:p>

</xml_diff>

<commit_message>
M03 PPTX: fix ambiguous bracket in Prompt Baik example (slide 4)
Split the italic 'PROMPT BAIK' quote into a separate context-note line
('Project sudah tahu positioning & produk-produkmu -- tidak perlu
ditulis ulang', styled like the deck's existing CATATAN note convention)
plus a clean quote with the bracket removed -- matching the HTML fix
from Checkpoint 80. Validated + visually QA'd, no overlap.
</commit_message>
<xml_diff>
--- a/Content-Marketing/M03-Konten-Instagram/K3-M03-Sistem-Konten-Instagram.pptx
+++ b/Content-Marketing/M03-Konten-Instagram/K3-M03-Sistem-Konten-Instagram.pptx
@@ -4072,7 +4072,7 @@
         </p:nvSpPr>
         <p:spPr>
           <a:xfrm>
-            <a:off x="6373368" y="2670048"/>
+            <a:off x="6373368" y="2930048"/>
             <a:ext cx="4764024" cy="1280160"/>
           </a:xfrm>
           <a:prstGeom prst="rect">
@@ -4100,7 +4100,7 @@
                 <a:ea typeface="Helvetica" pitchFamily="34" charset="-122"/>
                 <a:cs typeface="Helvetica" pitchFamily="34" charset="-120"/>
               </a:rPr>
-              <a:t>"[Project ini sudah tahu positioning dan produk-produkku] Buatkan kalender Instagram Juli — 16 post (4/minggu): 1 produk, 1 edukasi, 1 BTS, 1 testimoni. Tiap post: tema, caption maks 80 kata, 8 hashtag. Format tabel."</a:t>
+              <a:t>"Buatkan kalender Instagram Juli — 16 post (4/minggu): 1 produk, 1 edukasi, 1 BTS, 1 testimoni. Tiap post: tema, caption maks 80 kata, 8 hashtag. Format tabel."</a:t>
             </a:r>
             <a:endParaRPr lang="en-US" sz="1200" dirty="0"/>
           </a:p>
@@ -4229,6 +4229,48 @@
                 <a:cs typeface="Helvetica" pitchFamily="34" charset="-120"/>
               </a:rPr>
               <a:t>file cm-kalender-konten.xlsx (template 16 slot posting per bulan), akun Instagram bisnis aktif + 5-10 foto produk, dan Canva Connector aktif (opsional). Positioning dan katalog produk dari Modul 1-2 sudah otomatis tersedia kalau kamu masih di Project yang sama.</a:t>
+            </a:r>
+            <a:endParaRPr lang="en-US" sz="1200" dirty="0"/>
+          </a:p>
+        </p:txBody>
+      </p:sp>
+      <p:sp>
+        <p:nvSpPr>
+          <p:cNvPr id="18" name="Text 30"/>
+          <p:cNvSpPr/>
+          <p:nvPr/>
+        </p:nvSpPr>
+        <p:spPr>
+          <a:xfrm>
+            <a:off x="6373368" y="2646000"/>
+            <a:ext cx="4764024" cy="210000"/>
+          </a:xfrm>
+          <a:prstGeom prst="rect">
+            <a:avLst/>
+          </a:prstGeom>
+          <a:noFill/>
+          <a:ln/>
+        </p:spPr>
+        <p:txBody>
+          <a:bodyPr wrap="square" lIns="0" tIns="0" rIns="0" bIns="0" rtlCol="0" anchor="ctr"/>
+          <a:lstStyle/>
+          <a:p>
+            <a:pPr indent="0" marL="0">
+              <a:lnSpc>
+                <a:spcPct val="125000"/>
+              </a:lnSpc>
+              <a:buNone/>
+            </a:pPr>
+            <a:r>
+              <a:rPr lang="en-US" sz="1150" i="1" dirty="0" b="0">
+                <a:solidFill>
+                  <a:srgbClr val="6B7280"/>
+                </a:solidFill>
+                <a:latin typeface="Helvetica" pitchFamily="34" charset="0"/>
+                <a:ea typeface="Helvetica" pitchFamily="34" charset="-122"/>
+                <a:cs typeface="Helvetica" pitchFamily="34" charset="-120"/>
+              </a:rPr>
+              <a:t>Project sudah tahu positioning &amp; produk-produkmu — tidak perlu ditulis ulang</a:t>
             </a:r>
             <a:endParaRPr lang="en-US" sz="1200" dirty="0"/>
           </a:p>

</xml_diff>

<commit_message>
M03: fix HTML/PPTX prompt mismatch, switch to drag-and-drop xlsx workflow, make Latihan header prominent site-wide
</commit_message>
<xml_diff>
--- a/Content-Marketing/M03-Konten-Instagram/K3-M03-Sistem-Konten-Instagram.pptx
+++ b/Content-Marketing/M03-Konten-Instagram/K3-M03-Sistem-Konten-Instagram.pptx
@@ -2114,7 +2114,7 @@
                 <a:ea typeface="Helvetica" pitchFamily="34" charset="-122"/>
                 <a:cs typeface="Helvetica" pitchFamily="34" charset="-120"/>
               </a:rPr>
-              <a:t>Ide tema + format post + caption + hashtag untuk 30 hari dalam 1 prompt terstruktur</a:t>
+              <a:t>Ide tema, format, caption &amp; hashtag — tinggal lampirkan file, bukan copy-paste manual</a:t>
             </a:r>
             <a:endParaRPr lang="en-US" sz="1100" dirty="0"/>
           </a:p>
@@ -3803,7 +3803,7 @@
                 <a:ea typeface="Helvetica" pitchFamily="34" charset="-122"/>
                 <a:cs typeface="Helvetica" pitchFamily="34" charset="-120"/>
               </a:rPr>
-              <a:t>SATU PROMPT UNTUK 16 CAPTION SEKALIGUS</a:t>
+              <a:t>SATU PROMPT UNTUK 15 CAPTION SEKALIGUS</a:t>
             </a:r>
             <a:endParaRPr lang="en-US" sz="1250" dirty="0"/>
           </a:p>
@@ -4100,7 +4100,7 @@
                 <a:ea typeface="Helvetica" pitchFamily="34" charset="-122"/>
                 <a:cs typeface="Helvetica" pitchFamily="34" charset="-120"/>
               </a:rPr>
-              <a:t>Kerangka kalender bulan Juli saya sudah ada (No, Minggu, Hari, Kategori). Buatkan ide Tema, Format post, Caption maks 80 kata, dan 8 Hashtag tiap baris sesuai Kategori.</a:t>
+              <a:t>Ini file kalender kontenku (xlsx) — untuk baris 10-24, sesuai Kategori yang sudah ada, buatkan ide Tema, Format post, Caption maks 80 kata, dan 8 Hashtag.</a:t>
             </a:r>
             <a:endParaRPr lang="en-US" sz="1200" dirty="0"/>
           </a:p>
@@ -4142,7 +4142,7 @@
                 <a:ea typeface="Helvetica" pitchFamily="34" charset="-122"/>
                 <a:cs typeface="Helvetica" pitchFamily="34" charset="-120"/>
               </a:rPr>
-              <a:t>Kenapa berhasil: 1 prompt = ide tema + format + caption + hashtag lengkap, bukan cuma caption untuk ide yang sudah ditentukan.</a:t>
+              <a:t>Kenapa berhasil: 1 file lampiran = 15 ide konten lengkap — tidak perlu copy-paste manual, tidak ada risiko baris ketuker.</a:t>
             </a:r>
             <a:endParaRPr lang="en-US" sz="1150" dirty="0"/>
           </a:p>
@@ -4606,7 +4606,7 @@
                 <a:ea typeface="Helvetica" pitchFamily="34" charset="-122"/>
                 <a:cs typeface="Helvetica" pitchFamily="34" charset="-120"/>
               </a:rPr>
-              <a:t>Copy Kerangka Kalender — </a:t>
+              <a:t>Cek Kerangka Kalender — </a:t>
             </a:r>
             <a:pPr indent="0" marL="0">
               <a:lnSpc>
@@ -4623,7 +4623,7 @@
                 <a:ea typeface="Helvetica" pitchFamily="34" charset="-122"/>
                 <a:cs typeface="Helvetica" pitchFamily="34" charset="-120"/>
               </a:rPr>
-              <a:t>No, Minggu, Hari, Tanggal, Jam Post, Kategori (A-F) dari xlsx baris 10-24</a:t>
+              <a:t>sesuaikan tanggal &amp; promo bulan ini di xlsx baris 10-24 (rotasi 4 tema sudah ada)</a:t>
             </a:r>
             <a:endParaRPr lang="en-US" sz="1300" dirty="0"/>
           </a:p>
@@ -4724,7 +4724,7 @@
                 <a:ea typeface="Helvetica" pitchFamily="34" charset="-122"/>
                 <a:cs typeface="Helvetica" pitchFamily="34" charset="-120"/>
               </a:rPr>
-              <a:t>Generate Ide &amp; Copy — </a:t>
+              <a:t>Lampirkan &amp; Generate — </a:t>
             </a:r>
             <a:pPr indent="0" marL="0">
               <a:lnSpc>
@@ -4741,7 +4741,7 @@
                 <a:ea typeface="Helvetica" pitchFamily="34" charset="-122"/>
                 <a:cs typeface="Helvetica" pitchFamily="34" charset="-120"/>
               </a:rPr>
-              <a:t>Tema, Format, Caption &amp; Hashtag tiap baris sesuai Kategori — cocokkan pakai kolom No</a:t>
+              <a:t>drag &amp; drop xlsx ke Claude, minta ide Tema, Format, Caption &amp; Hashtag sesuai Kategori</a:t>
             </a:r>
             <a:endParaRPr lang="en-US" sz="1300" dirty="0"/>
           </a:p>
@@ -6142,7 +6142,7 @@
                 <a:ea typeface="Helvetica" pitchFamily="34" charset="-122"/>
                 <a:cs typeface="Helvetica" pitchFamily="34" charset="-120"/>
               </a:rPr>
-              <a:t>Copy kolom No-Jam Post (A:F) dari xlsx baris 10-24, jalankan prompt ini, lalu paste hasilnya ke kolom Tema/Format/Caption/Hashtag sesuai nomornya. Review, personalisasi, jadwalkan. Bonus: dashboard HTML, grafis Claude, foto via Prompt Enhancer.</a:t>
+              <a:t>Lampirkan xlsx ke Claude (drag &amp; drop), jalankan prompt ini untuk baris 10-24, lalu paste hasilnya ke kolom Tema/Format/Caption/Hashtag sesuai nomornya. Review, personalisasi, jadwalkan. Bonus: dashboard HTML, grafis Claude, foto via Prompt Enhancer.</a:t>
             </a:r>
             <a:endParaRPr lang="en-US" sz="1200" dirty="0"/>
           </a:p>
@@ -6211,7 +6211,7 @@
                 <a:ea typeface="Helvetica" pitchFamily="34" charset="-122"/>
                 <a:cs typeface="Helvetica" pitchFamily="34" charset="-120"/>
               </a:rPr>
-              <a:t>No | Minggu | Hari | Tanggal | Jam Post | Kategori — [paste baris 10-24 kolom A-F]. Buatkan ide Tema, Format post, Caption maks 80 kata &amp; Hashtag (8) tiap baris sesuai Kategori, cocokkan lewat No. Output: No | Tema | Format | Caption | Hashtag.</a:t>
+              <a:t>Ini file kalender kontenku, tab Kalender Konten. Untuk baris 10-24, sesuai Kategori yang sudah ada, buatkan ide Tema, Format post, Caption maks 80 kata &amp; Hashtag (8) tiap baris. Cocokkan lewat kolom No, jangan ubah urutan. Output: No | Tema | Format | Caption | Hashtag.</a:t>
             </a:r>
             <a:endParaRPr lang="en-US" sz="1000" dirty="0"/>
           </a:p>

</xml_diff>